<commit_message>
Update AERIS accident detection system
</commit_message>
<xml_diff>
--- a/Mini Project PPT.pptx
+++ b/Mini Project PPT.pptx
@@ -5,7 +5,7 @@
     <p:sldMasterId id="2147483648" r:id="rId1"/>
   </p:sldMasterIdLst>
   <p:notesMasterIdLst>
-    <p:notesMasterId r:id="rId12"/>
+    <p:notesMasterId r:id="rId13"/>
   </p:notesMasterIdLst>
   <p:sldIdLst>
     <p:sldId id="256" r:id="rId2"/>
@@ -17,7 +17,8 @@
     <p:sldId id="262" r:id="rId8"/>
     <p:sldId id="263" r:id="rId9"/>
     <p:sldId id="264" r:id="rId10"/>
-    <p:sldId id="265" r:id="rId11"/>
+    <p:sldId id="266" r:id="rId11"/>
+    <p:sldId id="265" r:id="rId12"/>
   </p:sldIdLst>
   <p:sldSz cx="9144000" cy="6858000" type="screen4x3"/>
   <p:notesSz cx="6858000" cy="9144000"/>
@@ -806,7 +807,7 @@
           <a:p>
             <a:fld id="{B254C9FA-0055-43BC-B023-48B23A08237D}" type="datetimeFigureOut">
               <a:rPr lang="en-US" smtClean="0"/>
-              <a:t>8/26/2026</a:t>
+              <a:t>10/13/2026</a:t>
             </a:fld>
             <a:endParaRPr lang="en-US" dirty="0"/>
           </a:p>
@@ -977,7 +978,7 @@
           <a:p>
             <a:fld id="{B254C9FA-0055-43BC-B023-48B23A08237D}" type="datetimeFigureOut">
               <a:rPr lang="en-US" smtClean="0"/>
-              <a:t>8/26/2026</a:t>
+              <a:t>10/13/2026</a:t>
             </a:fld>
             <a:endParaRPr lang="en-US" dirty="0"/>
           </a:p>
@@ -1158,7 +1159,7 @@
           <a:p>
             <a:fld id="{B254C9FA-0055-43BC-B023-48B23A08237D}" type="datetimeFigureOut">
               <a:rPr lang="en-US" smtClean="0"/>
-              <a:t>8/26/2026</a:t>
+              <a:t>10/13/2026</a:t>
             </a:fld>
             <a:endParaRPr lang="en-US" dirty="0"/>
           </a:p>
@@ -1329,7 +1330,7 @@
           <a:p>
             <a:fld id="{B254C9FA-0055-43BC-B023-48B23A08237D}" type="datetimeFigureOut">
               <a:rPr lang="en-US" smtClean="0"/>
-              <a:t>8/26/2026</a:t>
+              <a:t>10/13/2026</a:t>
             </a:fld>
             <a:endParaRPr lang="en-US" dirty="0"/>
           </a:p>
@@ -1577,7 +1578,7 @@
           <a:p>
             <a:fld id="{B254C9FA-0055-43BC-B023-48B23A08237D}" type="datetimeFigureOut">
               <a:rPr lang="en-US" smtClean="0"/>
-              <a:t>8/26/2026</a:t>
+              <a:t>10/13/2026</a:t>
             </a:fld>
             <a:endParaRPr lang="en-US" dirty="0"/>
           </a:p>
@@ -1865,7 +1866,7 @@
           <a:p>
             <a:fld id="{B254C9FA-0055-43BC-B023-48B23A08237D}" type="datetimeFigureOut">
               <a:rPr lang="en-US" smtClean="0"/>
-              <a:t>8/26/2026</a:t>
+              <a:t>10/13/2026</a:t>
             </a:fld>
             <a:endParaRPr lang="en-US" dirty="0"/>
           </a:p>
@@ -2283,7 +2284,7 @@
           <a:p>
             <a:fld id="{B254C9FA-0055-43BC-B023-48B23A08237D}" type="datetimeFigureOut">
               <a:rPr lang="en-US" smtClean="0"/>
-              <a:t>8/26/2026</a:t>
+              <a:t>10/13/2026</a:t>
             </a:fld>
             <a:endParaRPr lang="en-US" dirty="0"/>
           </a:p>
@@ -2403,7 +2404,7 @@
           <a:p>
             <a:fld id="{B254C9FA-0055-43BC-B023-48B23A08237D}" type="datetimeFigureOut">
               <a:rPr lang="en-US" smtClean="0"/>
-              <a:t>8/26/2026</a:t>
+              <a:t>10/13/2026</a:t>
             </a:fld>
             <a:endParaRPr lang="en-US" dirty="0"/>
           </a:p>
@@ -2501,7 +2502,7 @@
           <a:p>
             <a:fld id="{B254C9FA-0055-43BC-B023-48B23A08237D}" type="datetimeFigureOut">
               <a:rPr lang="en-US" smtClean="0"/>
-              <a:t>8/26/2026</a:t>
+              <a:t>10/13/2026</a:t>
             </a:fld>
             <a:endParaRPr lang="en-US" dirty="0"/>
           </a:p>
@@ -2779,7 +2780,7 @@
           <a:p>
             <a:fld id="{B254C9FA-0055-43BC-B023-48B23A08237D}" type="datetimeFigureOut">
               <a:rPr lang="en-US" smtClean="0"/>
-              <a:t>8/26/2026</a:t>
+              <a:t>10/13/2026</a:t>
             </a:fld>
             <a:endParaRPr lang="en-US" dirty="0"/>
           </a:p>
@@ -3034,7 +3035,7 @@
           <a:p>
             <a:fld id="{B254C9FA-0055-43BC-B023-48B23A08237D}" type="datetimeFigureOut">
               <a:rPr lang="en-US" smtClean="0"/>
-              <a:t>8/26/2026</a:t>
+              <a:t>10/13/2026</a:t>
             </a:fld>
             <a:endParaRPr lang="en-US" dirty="0"/>
           </a:p>
@@ -3248,7 +3249,7 @@
           <a:p>
             <a:fld id="{B254C9FA-0055-43BC-B023-48B23A08237D}" type="datetimeFigureOut">
               <a:rPr lang="en-US" smtClean="0"/>
-              <a:t>8/26/2026</a:t>
+              <a:t>10/13/2026</a:t>
             </a:fld>
             <a:endParaRPr lang="en-US" dirty="0"/>
           </a:p>
@@ -3800,6 +3801,366 @@
 <file path=ppt/slides/slide10.xml><?xml version="1.0" encoding="utf-8"?>
 <p:sld xmlns:a="http://schemas.openxmlformats.org/drawingml/2006/main" xmlns:r="http://schemas.openxmlformats.org/officeDocument/2006/relationships" xmlns:p="http://schemas.openxmlformats.org/presentationml/2006/main">
   <p:cSld>
+    <p:spTree>
+      <p:nvGrpSpPr>
+        <p:cNvPr id="1" name="">
+          <a:extLst>
+            <a:ext uri="{FF2B5EF4-FFF2-40B4-BE49-F238E27FC236}">
+              <a16:creationId xmlns:a16="http://schemas.microsoft.com/office/drawing/2014/main" id="{548C407B-03E4-57B0-313F-2B91C8725A9B}"/>
+            </a:ext>
+          </a:extLst>
+        </p:cNvPr>
+        <p:cNvGrpSpPr/>
+        <p:nvPr/>
+      </p:nvGrpSpPr>
+      <p:grpSpPr>
+        <a:xfrm>
+          <a:off x="0" y="0"/>
+          <a:ext cx="0" cy="0"/>
+          <a:chOff x="0" y="0"/>
+          <a:chExt cx="0" cy="0"/>
+        </a:xfrm>
+      </p:grpSpPr>
+      <p:sp>
+        <p:nvSpPr>
+          <p:cNvPr id="1048604" name="Rectangle 3">
+            <a:extLst>
+              <a:ext uri="{FF2B5EF4-FFF2-40B4-BE49-F238E27FC236}">
+                <a16:creationId xmlns:a16="http://schemas.microsoft.com/office/drawing/2014/main" id="{37D25EA3-D7BE-A8E3-69C8-43C8E9D1F591}"/>
+              </a:ext>
+            </a:extLst>
+          </p:cNvPr>
+          <p:cNvSpPr/>
+          <p:nvPr/>
+        </p:nvSpPr>
+        <p:spPr>
+          <a:xfrm>
+            <a:off x="0" y="0"/>
+            <a:ext cx="9144000" cy="914400"/>
+          </a:xfrm>
+          <a:prstGeom prst="rect">
+            <a:avLst/>
+          </a:prstGeom>
+        </p:spPr>
+        <p:style>
+          <a:lnRef idx="0">
+            <a:schemeClr val="accent1"/>
+          </a:lnRef>
+          <a:fillRef idx="3">
+            <a:schemeClr val="accent1"/>
+          </a:fillRef>
+          <a:effectRef idx="3">
+            <a:schemeClr val="accent1"/>
+          </a:effectRef>
+          <a:fontRef idx="minor">
+            <a:schemeClr val="lt1"/>
+          </a:fontRef>
+        </p:style>
+        <p:txBody>
+          <a:bodyPr rtlCol="0" anchor="ctr"/>
+          <a:lstStyle/>
+          <a:p>
+            <a:pPr algn="ctr"/>
+            <a:r>
+              <a:rPr lang="en-IN" sz="4000" b="1" dirty="0">
+                <a:latin typeface="Times New Roman" pitchFamily="18" charset="0"/>
+                <a:cs typeface="Times New Roman" pitchFamily="18" charset="0"/>
+              </a:rPr>
+              <a:t>SDG GOALS</a:t>
+            </a:r>
+            <a:endParaRPr lang="en-US" sz="4000" b="1" dirty="0">
+              <a:latin typeface="Times New Roman" pitchFamily="18" charset="0"/>
+              <a:cs typeface="Times New Roman" pitchFamily="18" charset="0"/>
+            </a:endParaRPr>
+          </a:p>
+        </p:txBody>
+      </p:sp>
+      <p:sp>
+        <p:nvSpPr>
+          <p:cNvPr id="1048605" name="Rectangle 4">
+            <a:extLst>
+              <a:ext uri="{FF2B5EF4-FFF2-40B4-BE49-F238E27FC236}">
+                <a16:creationId xmlns:a16="http://schemas.microsoft.com/office/drawing/2014/main" id="{AB0F4AE8-4D1C-4D50-D09E-E6570266D278}"/>
+              </a:ext>
+            </a:extLst>
+          </p:cNvPr>
+          <p:cNvSpPr/>
+          <p:nvPr/>
+        </p:nvSpPr>
+        <p:spPr>
+          <a:xfrm>
+            <a:off x="6567932" y="6028582"/>
+            <a:ext cx="2590800" cy="838200"/>
+          </a:xfrm>
+          <a:prstGeom prst="rect">
+            <a:avLst/>
+          </a:prstGeom>
+        </p:spPr>
+        <p:style>
+          <a:lnRef idx="0">
+            <a:schemeClr val="accent1"/>
+          </a:lnRef>
+          <a:fillRef idx="3">
+            <a:schemeClr val="accent1"/>
+          </a:fillRef>
+          <a:effectRef idx="3">
+            <a:schemeClr val="accent1"/>
+          </a:effectRef>
+          <a:fontRef idx="minor">
+            <a:schemeClr val="lt1"/>
+          </a:fontRef>
+        </p:style>
+        <p:txBody>
+          <a:bodyPr rtlCol="0" anchor="ctr"/>
+          <a:lstStyle/>
+          <a:p>
+            <a:pPr algn="ctr"/>
+            <a:r>
+              <a:rPr lang="en-US" sz="2000" b="1">
+                <a:latin typeface="Arial Rounded MT Bold" pitchFamily="34" charset="0"/>
+              </a:rPr>
+              <a:t>AI</a:t>
+            </a:r>
+            <a:r>
+              <a:rPr lang="en-US" sz="2000" b="1" dirty="0">
+                <a:latin typeface="Arial Rounded MT Bold" pitchFamily="34" charset="0"/>
+              </a:rPr>
+              <a:t>&amp;DS</a:t>
+            </a:r>
+          </a:p>
+        </p:txBody>
+      </p:sp>
+      <p:sp>
+        <p:nvSpPr>
+          <p:cNvPr id="1048606" name="Rectangle 5">
+            <a:extLst>
+              <a:ext uri="{FF2B5EF4-FFF2-40B4-BE49-F238E27FC236}">
+                <a16:creationId xmlns:a16="http://schemas.microsoft.com/office/drawing/2014/main" id="{6AACEAFF-0A3A-83BD-F3B9-B9A3C0D69382}"/>
+              </a:ext>
+            </a:extLst>
+          </p:cNvPr>
+          <p:cNvSpPr/>
+          <p:nvPr/>
+        </p:nvSpPr>
+        <p:spPr>
+          <a:xfrm>
+            <a:off x="-6928" y="6019800"/>
+            <a:ext cx="2978727" cy="838200"/>
+          </a:xfrm>
+          <a:prstGeom prst="rect">
+            <a:avLst/>
+          </a:prstGeom>
+        </p:spPr>
+        <p:style>
+          <a:lnRef idx="0">
+            <a:schemeClr val="accent3"/>
+          </a:lnRef>
+          <a:fillRef idx="3">
+            <a:schemeClr val="accent3"/>
+          </a:fillRef>
+          <a:effectRef idx="3">
+            <a:schemeClr val="accent3"/>
+          </a:effectRef>
+          <a:fontRef idx="minor">
+            <a:schemeClr val="lt1"/>
+          </a:fontRef>
+        </p:style>
+        <p:txBody>
+          <a:bodyPr rtlCol="0" anchor="ctr"/>
+          <a:lstStyle/>
+          <a:p>
+            <a:pPr algn="ctr"/>
+            <a:r>
+              <a:rPr lang="en-US" sz="2000" dirty="0">
+                <a:solidFill>
+                  <a:prstClr val="black"/>
+                </a:solidFill>
+              </a:rPr>
+              <a:t> </a:t>
+            </a:r>
+          </a:p>
+          <a:p>
+            <a:pPr algn="ctr"/>
+            <a:r>
+              <a:rPr lang="en-US" sz="2000" dirty="0">
+                <a:solidFill>
+                  <a:schemeClr val="tx1"/>
+                </a:solidFill>
+              </a:rPr>
+              <a:t>AERIS</a:t>
+            </a:r>
+          </a:p>
+          <a:p>
+            <a:pPr lvl="0" algn="ctr"/>
+            <a:endParaRPr lang="en-US" sz="2000" dirty="0">
+              <a:solidFill>
+                <a:prstClr val="black"/>
+              </a:solidFill>
+            </a:endParaRPr>
+          </a:p>
+        </p:txBody>
+      </p:sp>
+      <p:pic>
+        <p:nvPicPr>
+          <p:cNvPr id="2097156" name="Picture 2">
+            <a:extLst>
+              <a:ext uri="{FF2B5EF4-FFF2-40B4-BE49-F238E27FC236}">
+                <a16:creationId xmlns:a16="http://schemas.microsoft.com/office/drawing/2014/main" id="{2C2266F0-613B-1625-50FF-A7AF30FC4004}"/>
+              </a:ext>
+            </a:extLst>
+          </p:cNvPr>
+          <p:cNvPicPr>
+            <a:picLocks noChangeAspect="1" noChangeArrowheads="1"/>
+          </p:cNvPicPr>
+          <p:nvPr/>
+        </p:nvPicPr>
+        <p:blipFill>
+          <a:blip r:embed="rId2"/>
+          <a:srcRect/>
+          <a:stretch>
+            <a:fillRect/>
+          </a:stretch>
+        </p:blipFill>
+        <p:spPr bwMode="auto">
+          <a:xfrm>
+            <a:off x="2971799" y="6019801"/>
+            <a:ext cx="3581401" cy="838200"/>
+          </a:xfrm>
+          <a:prstGeom prst="rect">
+            <a:avLst/>
+          </a:prstGeom>
+          <a:noFill/>
+          <a:ln>
+            <a:noFill/>
+          </a:ln>
+          <a:effectLst/>
+        </p:spPr>
+      </p:pic>
+      <p:sp>
+        <p:nvSpPr>
+          <p:cNvPr id="6" name="Content Placeholder 2">
+            <a:extLst>
+              <a:ext uri="{FF2B5EF4-FFF2-40B4-BE49-F238E27FC236}">
+                <a16:creationId xmlns:a16="http://schemas.microsoft.com/office/drawing/2014/main" id="{B20F9798-B445-04B3-DB8C-6A4D3A07CCD3}"/>
+              </a:ext>
+            </a:extLst>
+          </p:cNvPr>
+          <p:cNvSpPr>
+            <a:spLocks noGrp="1"/>
+          </p:cNvSpPr>
+          <p:nvPr>
+            <p:ph idx="1"/>
+          </p:nvPr>
+        </p:nvSpPr>
+        <p:spPr>
+          <a:xfrm>
+            <a:off x="399411" y="1178921"/>
+            <a:ext cx="8345178" cy="4849661"/>
+          </a:xfrm>
+        </p:spPr>
+        <p:txBody>
+          <a:bodyPr>
+            <a:normAutofit/>
+          </a:bodyPr>
+          <a:lstStyle/>
+          <a:p>
+            <a:pPr marL="0" indent="0" algn="just">
+              <a:buNone/>
+            </a:pPr>
+            <a:endParaRPr lang="en-US" sz="2400" dirty="0">
+              <a:latin typeface="Times New Roman" pitchFamily="18" charset="0"/>
+              <a:cs typeface="Times New Roman" pitchFamily="18" charset="0"/>
+            </a:endParaRPr>
+          </a:p>
+          <a:p>
+            <a:pPr>
+              <a:buFont typeface="Wingdings" panose="05000000000000000000" pitchFamily="2" charset="2"/>
+              <a:buChar char="Ø"/>
+            </a:pPr>
+            <a:r>
+              <a:rPr lang="en-IN" sz="2800" b="1" dirty="0"/>
+              <a:t>SDG 3:</a:t>
+            </a:r>
+            <a:r>
+              <a:rPr lang="en-IN" sz="2800" dirty="0"/>
+              <a:t> Good Health and Well-Being.</a:t>
+            </a:r>
+          </a:p>
+          <a:p>
+            <a:pPr>
+              <a:buFont typeface="Wingdings" panose="05000000000000000000" pitchFamily="2" charset="2"/>
+              <a:buChar char="Ø"/>
+            </a:pPr>
+            <a:r>
+              <a:rPr lang="en-IN" sz="2800" b="1" dirty="0"/>
+              <a:t>SDG 9: </a:t>
+            </a:r>
+            <a:r>
+              <a:rPr lang="en-IN" sz="2800" dirty="0"/>
+              <a:t>Industry, Innovation, and Infrastructure.</a:t>
+            </a:r>
+          </a:p>
+          <a:p>
+            <a:pPr>
+              <a:buFont typeface="Wingdings" panose="05000000000000000000" pitchFamily="2" charset="2"/>
+              <a:buChar char="Ø"/>
+            </a:pPr>
+            <a:r>
+              <a:rPr lang="en-IN" sz="2800" b="1" dirty="0"/>
+              <a:t> SDG 11:</a:t>
+            </a:r>
+            <a:r>
+              <a:rPr lang="en-IN" sz="2800" dirty="0"/>
+              <a:t> Sustainable Cities and Communities.</a:t>
+            </a:r>
+          </a:p>
+          <a:p>
+            <a:pPr>
+              <a:buFont typeface="Wingdings" panose="05000000000000000000" pitchFamily="2" charset="2"/>
+              <a:buChar char="Ø"/>
+            </a:pPr>
+            <a:r>
+              <a:rPr lang="en-IN" sz="2800" b="1" dirty="0"/>
+              <a:t> SDG 17: </a:t>
+            </a:r>
+            <a:r>
+              <a:rPr lang="en-IN" sz="2800" dirty="0"/>
+              <a:t>Partnerships for the Goals (Multi-Department Collaboration)</a:t>
+            </a:r>
+          </a:p>
+          <a:p>
+            <a:pPr>
+              <a:buFont typeface="Wingdings" panose="05000000000000000000" pitchFamily="2" charset="2"/>
+              <a:buChar char="Ø"/>
+            </a:pPr>
+            <a:endParaRPr lang="en-IN" sz="2400" b="1" dirty="0"/>
+          </a:p>
+        </p:txBody>
+      </p:sp>
+    </p:spTree>
+    <p:extLst>
+      <p:ext uri="{BB962C8B-B14F-4D97-AF65-F5344CB8AC3E}">
+        <p14:creationId xmlns:p14="http://schemas.microsoft.com/office/powerpoint/2010/main" val="86785614"/>
+      </p:ext>
+    </p:extLst>
+  </p:cSld>
+  <p:clrMapOvr>
+    <a:masterClrMapping/>
+  </p:clrMapOvr>
+  <mc:AlternateContent xmlns:mc="http://schemas.openxmlformats.org/markup-compatibility/2006" xmlns:p14="http://schemas.microsoft.com/office/powerpoint/2010/main">
+    <mc:Choice Requires="p14">
+      <p:transition spd="slow" p14:dur="2000" advTm="5000"/>
+    </mc:Choice>
+    <mc:Fallback xmlns="">
+      <p:transition spd="slow" advTm="5000"/>
+    </mc:Fallback>
+  </mc:AlternateContent>
+</p:sld>
+</file>
+
+<file path=ppt/slides/slide11.xml><?xml version="1.0" encoding="utf-8"?>
+<p:sld xmlns:a="http://schemas.openxmlformats.org/drawingml/2006/main" xmlns:r="http://schemas.openxmlformats.org/officeDocument/2006/relationships" xmlns:p="http://schemas.openxmlformats.org/presentationml/2006/main">
+  <p:cSld>
     <p:bg>
       <p:bgPr>
         <a:solidFill>
@@ -3907,13 +4268,8 @@
                   <a:schemeClr val="tx1"/>
                 </a:solidFill>
               </a:rPr>
-              <a:t>ACCIDENT DETECTION</a:t>
-            </a:r>
-            <a:endParaRPr lang="en-US" sz="2000" dirty="0">
-              <a:solidFill>
-                <a:prstClr val="black"/>
-              </a:solidFill>
-            </a:endParaRPr>
+              <a:t>AERIS</a:t>
+            </a:r>
           </a:p>
         </p:txBody>
       </p:sp>
@@ -4248,14 +4604,14 @@
                 <a:latin typeface="Times New Roman" panose="02020603050405020304" pitchFamily="18" charset="0"/>
                 <a:cs typeface="Times New Roman" panose="02020603050405020304" pitchFamily="18" charset="0"/>
               </a:rPr>
-              <a:t>Mr. P. </a:t>
-            </a:r>
-            <a:r>
-              <a:rPr lang="en-US" sz="2400" b="1">
+              <a:t>Mr. P. Vasantha </a:t>
+            </a:r>
+            <a:r>
+              <a:rPr lang="en-US" sz="2400" b="1" dirty="0" err="1">
                 <a:latin typeface="Times New Roman" panose="02020603050405020304" pitchFamily="18" charset="0"/>
                 <a:cs typeface="Times New Roman" panose="02020603050405020304" pitchFamily="18" charset="0"/>
               </a:rPr>
-              <a:t>Vasantha kumar</a:t>
+              <a:t>kumar</a:t>
             </a:r>
             <a:r>
               <a:rPr lang="en-US" sz="2400" b="1" dirty="0">
@@ -4668,7 +5024,7 @@
                   <a:schemeClr val="tx1"/>
                 </a:solidFill>
               </a:rPr>
-              <a:t>ACCIDENT DETECTION</a:t>
+              <a:t>AERIS</a:t>
             </a:r>
           </a:p>
         </p:txBody>
@@ -4870,12 +5226,12 @@
           <a:p>
             <a:pPr algn="ctr"/>
             <a:r>
-              <a:rPr lang="en-US" dirty="0">
+              <a:rPr lang="en-US" sz="2000" dirty="0">
                 <a:solidFill>
                   <a:schemeClr val="tx1"/>
                 </a:solidFill>
               </a:rPr>
-              <a:t>ACCIDENT DETECTION</a:t>
+              <a:t>AERIS</a:t>
             </a:r>
             <a:endParaRPr lang="en-US" sz="1800" dirty="0">
               <a:solidFill>
@@ -4939,7 +5295,7 @@
         </p:blipFill>
         <p:spPr>
           <a:xfrm>
-            <a:off x="590308" y="1213104"/>
+            <a:off x="590308" y="1222248"/>
             <a:ext cx="8171727" cy="4495800"/>
           </a:xfrm>
           <a:prstGeom prst="rect">
@@ -5104,10 +5460,10 @@
             <a:r>
               <a:rPr lang="en-US" sz="2000" dirty="0">
                 <a:solidFill>
-                  <a:prstClr val="black"/>
+                  <a:schemeClr val="tx1"/>
                 </a:solidFill>
               </a:rPr>
-              <a:t>ACCIDENT DETECTION</a:t>
+              <a:t>AERIS</a:t>
             </a:r>
           </a:p>
         </p:txBody>
@@ -5719,13 +6075,8 @@
                   <a:schemeClr val="tx1"/>
                 </a:solidFill>
               </a:rPr>
-              <a:t>ACCIDENT DETECTION</a:t>
-            </a:r>
-            <a:endParaRPr lang="en-US" sz="2000" dirty="0">
-              <a:solidFill>
-                <a:prstClr val="black"/>
-              </a:solidFill>
-            </a:endParaRPr>
+              <a:t>AERIS</a:t>
+            </a:r>
           </a:p>
         </p:txBody>
       </p:sp>
@@ -6218,13 +6569,8 @@
                   <a:schemeClr val="tx1"/>
                 </a:solidFill>
               </a:rPr>
-              <a:t>ACCIDENT DETECTION</a:t>
-            </a:r>
-            <a:endParaRPr lang="en-US" sz="2000" dirty="0">
-              <a:solidFill>
-                <a:prstClr val="black"/>
-              </a:solidFill>
-            </a:endParaRPr>
+              <a:t>AERIS</a:t>
+            </a:r>
           </a:p>
         </p:txBody>
       </p:sp>
@@ -6617,13 +6963,8 @@
                   <a:schemeClr val="tx1"/>
                 </a:solidFill>
               </a:rPr>
-              <a:t>ACCIDENT DETECTION</a:t>
-            </a:r>
-            <a:endParaRPr lang="en-US" sz="2000" dirty="0">
-              <a:solidFill>
-                <a:prstClr val="black"/>
-              </a:solidFill>
-            </a:endParaRPr>
+              <a:t>AERIS</a:t>
+            </a:r>
           </a:p>
         </p:txBody>
       </p:sp>
@@ -6929,13 +7270,8 @@
                   <a:schemeClr val="tx1"/>
                 </a:solidFill>
               </a:rPr>
-              <a:t>ACCIDENT DETECTION</a:t>
-            </a:r>
-            <a:endParaRPr lang="en-US" sz="2000" dirty="0">
-              <a:solidFill>
-                <a:prstClr val="black"/>
-              </a:solidFill>
-            </a:endParaRPr>
+              <a:t>AERIS</a:t>
+            </a:r>
           </a:p>
           <a:p>
             <a:pPr lvl="0" algn="ctr"/>

</xml_diff>